<commit_message>
Add a slide for each workshop exercise
Insert six 'Title and Content' slides (one per exercise) between the
'Your workshop journey' overview table and the closing 'Thank you'
slide. Each slide shows the exercise number, duration and a short
list of objectives/skills, styled to match the deck:

1. Setup & Basics
2. Comment-to-Code
3. Code Completion
4. Copilot Chat
5. Real-World Project
6. Agents, Skills & MCP (bonus)

Co-authored-by: Copilot App <223556219+Copilot@users.noreply.github.com>
</commit_message>
<xml_diff>
--- a/resources/github-copilot-workshop.pptx
+++ b/resources/github-copilot-workshop.pptx
@@ -15,6 +15,12 @@
     <p:sldId id="658" r:id="rId9"/>
     <p:sldId id="659" r:id="rId10"/>
     <p:sldId id="660" r:id="rId11"/>
+    <p:sldId id="661" r:id="rId18"/>
+    <p:sldId id="662" r:id="rId19"/>
+    <p:sldId id="663" r:id="rId20"/>
+    <p:sldId id="664" r:id="rId21"/>
+    <p:sldId id="665" r:id="rId22"/>
+    <p:sldId id="666" r:id="rId23"/>
     <p:sldId id="582" r:id="rId12"/>
   </p:sldIdLst>
   <p:sldSz cx="12188825" cy="6858000"/>
@@ -6742,6 +6748,571 @@
 </p:sld>
 </file>
 
+<file path=ppt/slides/slide10.xml><?xml version="1.0" encoding="utf-8"?>
+<p:sld xmlns:a="http://schemas.openxmlformats.org/drawingml/2006/main" xmlns:p="http://schemas.openxmlformats.org/presentationml/2006/main" xmlns:r="http://schemas.openxmlformats.org/officeDocument/2006/relationships">
+  <p:cSld>
+    <p:spTree>
+      <p:nvGrpSpPr>
+        <p:cNvPr id="1" name=""/>
+        <p:cNvGrpSpPr/>
+        <p:nvPr/>
+      </p:nvGrpSpPr>
+      <p:grpSpPr/>
+      <p:sp>
+        <p:nvSpPr>
+          <p:cNvPr id="2" name="Content Placeholder 1"/>
+          <p:cNvSpPr>
+            <a:spLocks noGrp="1"/>
+          </p:cNvSpPr>
+          <p:nvPr>
+            <p:ph idx="1"/>
+          </p:nvPr>
+        </p:nvSpPr>
+        <p:spPr/>
+        <p:txBody>
+          <a:bodyPr/>
+          <a:lstStyle/>
+          <a:p>
+            <a:r>
+              <a:t>Write clear comments that generate high-quality code.</a:t>
+            </a:r>
+          </a:p>
+          <a:p>
+            <a:r>
+              <a:t>Build data-structure, algorithm and business-logic functions.</a:t>
+            </a:r>
+          </a:p>
+          <a:p>
+            <a:r>
+              <a:t>Generate test cases straight from your comments.</a:t>
+            </a:r>
+          </a:p>
+          <a:p>
+            <a:r>
+              <a:t>Learn why specificity — inputs, outputs, edge cases — matters.</a:t>
+            </a:r>
+          </a:p>
+        </p:txBody>
+      </p:sp>
+      <p:sp>
+        <p:nvSpPr>
+          <p:cNvPr id="3" name="Text Placeholder 2"/>
+          <p:cNvSpPr>
+            <a:spLocks noGrp="1"/>
+          </p:cNvSpPr>
+          <p:nvPr>
+            <p:ph type="body" idx="32" sz="quarter"/>
+          </p:nvPr>
+        </p:nvSpPr>
+        <p:spPr/>
+        <p:txBody>
+          <a:bodyPr/>
+          <a:lstStyle/>
+          <a:p>
+            <a:r>
+              <a:t>Exercise 02 · 30 min</a:t>
+            </a:r>
+          </a:p>
+        </p:txBody>
+      </p:sp>
+      <p:sp>
+        <p:nvSpPr>
+          <p:cNvPr id="4" name="Title 3"/>
+          <p:cNvSpPr>
+            <a:spLocks noGrp="1"/>
+          </p:cNvSpPr>
+          <p:nvPr>
+            <p:ph type="ctrTitle"/>
+          </p:nvPr>
+        </p:nvSpPr>
+        <p:spPr/>
+        <p:txBody>
+          <a:bodyPr/>
+          <a:lstStyle/>
+          <a:p>
+            <a:r>
+              <a:t>Comment-to-Code</a:t>
+            </a:r>
+          </a:p>
+        </p:txBody>
+      </p:sp>
+      <p:sp>
+        <p:nvSpPr>
+          <p:cNvPr id="5" name="Text Placeholder 4"/>
+          <p:cNvSpPr>
+            <a:spLocks noGrp="1"/>
+          </p:cNvSpPr>
+          <p:nvPr>
+            <p:ph type="body" idx="10" sz="quarter"/>
+          </p:nvPr>
+        </p:nvSpPr>
+        <p:spPr/>
+        <p:txBody>
+          <a:bodyPr/>
+          <a:lstStyle/>
+          <a:p/>
+        </p:txBody>
+      </p:sp>
+    </p:spTree>
+  </p:cSld>
+  <p:clrMapOvr>
+    <a:masterClrMapping/>
+  </p:clrMapOvr>
+</p:sld>
+</file>
+
+<file path=ppt/slides/slide11.xml><?xml version="1.0" encoding="utf-8"?>
+<p:sld xmlns:a="http://schemas.openxmlformats.org/drawingml/2006/main" xmlns:p="http://schemas.openxmlformats.org/presentationml/2006/main" xmlns:r="http://schemas.openxmlformats.org/officeDocument/2006/relationships">
+  <p:cSld>
+    <p:spTree>
+      <p:nvGrpSpPr>
+        <p:cNvPr id="1" name=""/>
+        <p:cNvGrpSpPr/>
+        <p:nvPr/>
+      </p:nvGrpSpPr>
+      <p:grpSpPr/>
+      <p:sp>
+        <p:nvSpPr>
+          <p:cNvPr id="2" name="Content Placeholder 1"/>
+          <p:cNvSpPr>
+            <a:spLocks noGrp="1"/>
+          </p:cNvSpPr>
+          <p:nvPr>
+            <p:ph idx="1"/>
+          </p:nvPr>
+        </p:nvSpPr>
+        <p:spPr/>
+        <p:txBody>
+          <a:bodyPr/>
+          <a:lstStyle/>
+          <a:p>
+            <a:r>
+              <a:t>Master multi-line completion and working with partial code.</a:t>
+            </a:r>
+          </a:p>
+          <a:p>
+            <a:r>
+              <a:t>Complete functions, classes and async API calls.</a:t>
+            </a:r>
+          </a:p>
+          <a:p>
+            <a:r>
+              <a:t>Recognize loop, iteration and error-handling patterns.</a:t>
+            </a:r>
+          </a:p>
+          <a:p>
+            <a:r>
+              <a:t>Use context — names and imports — to steer suggestions.</a:t>
+            </a:r>
+          </a:p>
+        </p:txBody>
+      </p:sp>
+      <p:sp>
+        <p:nvSpPr>
+          <p:cNvPr id="3" name="Text Placeholder 2"/>
+          <p:cNvSpPr>
+            <a:spLocks noGrp="1"/>
+          </p:cNvSpPr>
+          <p:nvPr>
+            <p:ph type="body" idx="32" sz="quarter"/>
+          </p:nvPr>
+        </p:nvSpPr>
+        <p:spPr/>
+        <p:txBody>
+          <a:bodyPr/>
+          <a:lstStyle/>
+          <a:p>
+            <a:r>
+              <a:t>Exercise 03 · 30 min</a:t>
+            </a:r>
+          </a:p>
+        </p:txBody>
+      </p:sp>
+      <p:sp>
+        <p:nvSpPr>
+          <p:cNvPr id="4" name="Title 3"/>
+          <p:cNvSpPr>
+            <a:spLocks noGrp="1"/>
+          </p:cNvSpPr>
+          <p:nvPr>
+            <p:ph type="ctrTitle"/>
+          </p:nvPr>
+        </p:nvSpPr>
+        <p:spPr/>
+        <p:txBody>
+          <a:bodyPr/>
+          <a:lstStyle/>
+          <a:p>
+            <a:r>
+              <a:t>Code Completion</a:t>
+            </a:r>
+          </a:p>
+        </p:txBody>
+      </p:sp>
+      <p:sp>
+        <p:nvSpPr>
+          <p:cNvPr id="5" name="Text Placeholder 4"/>
+          <p:cNvSpPr>
+            <a:spLocks noGrp="1"/>
+          </p:cNvSpPr>
+          <p:nvPr>
+            <p:ph type="body" idx="10" sz="quarter"/>
+          </p:nvPr>
+        </p:nvSpPr>
+        <p:spPr/>
+        <p:txBody>
+          <a:bodyPr/>
+          <a:lstStyle/>
+          <a:p/>
+        </p:txBody>
+      </p:sp>
+    </p:spTree>
+  </p:cSld>
+  <p:clrMapOvr>
+    <a:masterClrMapping/>
+  </p:clrMapOvr>
+</p:sld>
+</file>
+
+<file path=ppt/slides/slide12.xml><?xml version="1.0" encoding="utf-8"?>
+<p:sld xmlns:a="http://schemas.openxmlformats.org/drawingml/2006/main" xmlns:p="http://schemas.openxmlformats.org/presentationml/2006/main" xmlns:r="http://schemas.openxmlformats.org/officeDocument/2006/relationships">
+  <p:cSld>
+    <p:spTree>
+      <p:nvGrpSpPr>
+        <p:cNvPr id="1" name=""/>
+        <p:cNvGrpSpPr/>
+        <p:nvPr/>
+      </p:nvGrpSpPr>
+      <p:grpSpPr/>
+      <p:sp>
+        <p:nvSpPr>
+          <p:cNvPr id="2" name="Content Placeholder 1"/>
+          <p:cNvSpPr>
+            <a:spLocks noGrp="1"/>
+          </p:cNvSpPr>
+          <p:nvPr>
+            <p:ph idx="1"/>
+          </p:nvPr>
+        </p:nvSpPr>
+        <p:spPr/>
+        <p:txBody>
+          <a:bodyPr/>
+          <a:lstStyle/>
+          <a:p>
+            <a:r>
+              <a:t>Explain, debug, document and test with Copilot Chat.</a:t>
+            </a:r>
+          </a:p>
+          <a:p>
+            <a:r>
+              <a:t>Use slash commands: /explain, /fix, /doc, /tests.</a:t>
+            </a:r>
+          </a:p>
+          <a:p>
+            <a:r>
+              <a:t>Optimize and refactor complex, nested functions.</a:t>
+            </a:r>
+          </a:p>
+          <a:p>
+            <a:r>
+              <a:t>Analyze code for security and quality issues.</a:t>
+            </a:r>
+          </a:p>
+        </p:txBody>
+      </p:sp>
+      <p:sp>
+        <p:nvSpPr>
+          <p:cNvPr id="3" name="Text Placeholder 2"/>
+          <p:cNvSpPr>
+            <a:spLocks noGrp="1"/>
+          </p:cNvSpPr>
+          <p:nvPr>
+            <p:ph type="body" idx="32" sz="quarter"/>
+          </p:nvPr>
+        </p:nvSpPr>
+        <p:spPr/>
+        <p:txBody>
+          <a:bodyPr/>
+          <a:lstStyle/>
+          <a:p>
+            <a:r>
+              <a:t>Exercise 04 · 45 min</a:t>
+            </a:r>
+          </a:p>
+        </p:txBody>
+      </p:sp>
+      <p:sp>
+        <p:nvSpPr>
+          <p:cNvPr id="4" name="Title 3"/>
+          <p:cNvSpPr>
+            <a:spLocks noGrp="1"/>
+          </p:cNvSpPr>
+          <p:nvPr>
+            <p:ph type="ctrTitle"/>
+          </p:nvPr>
+        </p:nvSpPr>
+        <p:spPr/>
+        <p:txBody>
+          <a:bodyPr/>
+          <a:lstStyle/>
+          <a:p>
+            <a:r>
+              <a:t>Copilot Chat</a:t>
+            </a:r>
+          </a:p>
+        </p:txBody>
+      </p:sp>
+      <p:sp>
+        <p:nvSpPr>
+          <p:cNvPr id="5" name="Text Placeholder 4"/>
+          <p:cNvSpPr>
+            <a:spLocks noGrp="1"/>
+          </p:cNvSpPr>
+          <p:nvPr>
+            <p:ph type="body" idx="10" sz="quarter"/>
+          </p:nvPr>
+        </p:nvSpPr>
+        <p:spPr/>
+        <p:txBody>
+          <a:bodyPr/>
+          <a:lstStyle/>
+          <a:p/>
+        </p:txBody>
+      </p:sp>
+    </p:spTree>
+  </p:cSld>
+  <p:clrMapOvr>
+    <a:masterClrMapping/>
+  </p:clrMapOvr>
+</p:sld>
+</file>
+
+<file path=ppt/slides/slide13.xml><?xml version="1.0" encoding="utf-8"?>
+<p:sld xmlns:a="http://schemas.openxmlformats.org/drawingml/2006/main" xmlns:p="http://schemas.openxmlformats.org/presentationml/2006/main" xmlns:r="http://schemas.openxmlformats.org/officeDocument/2006/relationships">
+  <p:cSld>
+    <p:spTree>
+      <p:nvGrpSpPr>
+        <p:cNvPr id="1" name=""/>
+        <p:cNvGrpSpPr/>
+        <p:nvPr/>
+      </p:nvGrpSpPr>
+      <p:grpSpPr/>
+      <p:sp>
+        <p:nvSpPr>
+          <p:cNvPr id="2" name="Content Placeholder 1"/>
+          <p:cNvSpPr>
+            <a:spLocks noGrp="1"/>
+          </p:cNvSpPr>
+          <p:nvPr>
+            <p:ph idx="1"/>
+          </p:nvPr>
+        </p:nvSpPr>
+        <p:spPr/>
+        <p:txBody>
+          <a:bodyPr/>
+          <a:lstStyle/>
+          <a:p>
+            <a:r>
+              <a:t>Build a complete Task Manager — REST API + web UI.</a:t>
+            </a:r>
+          </a:p>
+          <a:p>
+            <a:r>
+              <a:t>Express server backed by an in-memory task store.</a:t>
+            </a:r>
+          </a:p>
+          <a:p>
+            <a:r>
+              <a:t>Interactive frontend that updates without a refresh.</a:t>
+            </a:r>
+          </a:p>
+          <a:p>
+            <a:r>
+              <a:t>Verify end-to-end in the browser and with curl.</a:t>
+            </a:r>
+          </a:p>
+        </p:txBody>
+      </p:sp>
+      <p:sp>
+        <p:nvSpPr>
+          <p:cNvPr id="3" name="Text Placeholder 2"/>
+          <p:cNvSpPr>
+            <a:spLocks noGrp="1"/>
+          </p:cNvSpPr>
+          <p:nvPr>
+            <p:ph type="body" idx="32" sz="quarter"/>
+          </p:nvPr>
+        </p:nvSpPr>
+        <p:spPr/>
+        <p:txBody>
+          <a:bodyPr/>
+          <a:lstStyle/>
+          <a:p>
+            <a:r>
+              <a:t>Exercise 05 · 60 min</a:t>
+            </a:r>
+          </a:p>
+        </p:txBody>
+      </p:sp>
+      <p:sp>
+        <p:nvSpPr>
+          <p:cNvPr id="4" name="Title 3"/>
+          <p:cNvSpPr>
+            <a:spLocks noGrp="1"/>
+          </p:cNvSpPr>
+          <p:nvPr>
+            <p:ph type="ctrTitle"/>
+          </p:nvPr>
+        </p:nvSpPr>
+        <p:spPr/>
+        <p:txBody>
+          <a:bodyPr/>
+          <a:lstStyle/>
+          <a:p>
+            <a:r>
+              <a:t>Real-World Project</a:t>
+            </a:r>
+          </a:p>
+        </p:txBody>
+      </p:sp>
+      <p:sp>
+        <p:nvSpPr>
+          <p:cNvPr id="5" name="Text Placeholder 4"/>
+          <p:cNvSpPr>
+            <a:spLocks noGrp="1"/>
+          </p:cNvSpPr>
+          <p:nvPr>
+            <p:ph type="body" idx="10" sz="quarter"/>
+          </p:nvPr>
+        </p:nvSpPr>
+        <p:spPr/>
+        <p:txBody>
+          <a:bodyPr/>
+          <a:lstStyle/>
+          <a:p/>
+        </p:txBody>
+      </p:sp>
+    </p:spTree>
+  </p:cSld>
+  <p:clrMapOvr>
+    <a:masterClrMapping/>
+  </p:clrMapOvr>
+</p:sld>
+</file>
+
+<file path=ppt/slides/slide14.xml><?xml version="1.0" encoding="utf-8"?>
+<p:sld xmlns:a="http://schemas.openxmlformats.org/drawingml/2006/main" xmlns:p="http://schemas.openxmlformats.org/presentationml/2006/main" xmlns:r="http://schemas.openxmlformats.org/officeDocument/2006/relationships">
+  <p:cSld>
+    <p:spTree>
+      <p:nvGrpSpPr>
+        <p:cNvPr id="1" name=""/>
+        <p:cNvGrpSpPr/>
+        <p:nvPr/>
+      </p:nvGrpSpPr>
+      <p:grpSpPr/>
+      <p:sp>
+        <p:nvSpPr>
+          <p:cNvPr id="2" name="Content Placeholder 1"/>
+          <p:cNvSpPr>
+            <a:spLocks noGrp="1"/>
+          </p:cNvSpPr>
+          <p:nvPr>
+            <p:ph idx="1"/>
+          </p:nvPr>
+        </p:nvSpPr>
+        <p:spPr/>
+        <p:txBody>
+          <a:bodyPr/>
+          <a:lstStyle/>
+          <a:p>
+            <a:r>
+              <a:t>Orchestrate an end-to-end feature with a custom agent.</a:t>
+            </a:r>
+          </a:p>
+          <a:p>
+            <a:r>
+              <a:t>Add repo instructions and a reusable task-crud skill.</a:t>
+            </a:r>
+          </a:p>
+          <a:p>
+            <a:r>
+              <a:t>Drive and verify the UI with the Playwright MCP server.</a:t>
+            </a:r>
+          </a:p>
+          <a:p>
+            <a:r>
+              <a:t>Run the implement → verify → fix → re-verify loop.</a:t>
+            </a:r>
+          </a:p>
+        </p:txBody>
+      </p:sp>
+      <p:sp>
+        <p:nvSpPr>
+          <p:cNvPr id="3" name="Text Placeholder 2"/>
+          <p:cNvSpPr>
+            <a:spLocks noGrp="1"/>
+          </p:cNvSpPr>
+          <p:nvPr>
+            <p:ph type="body" idx="32" sz="quarter"/>
+          </p:nvPr>
+        </p:nvSpPr>
+        <p:spPr/>
+        <p:txBody>
+          <a:bodyPr/>
+          <a:lstStyle/>
+          <a:p>
+            <a:r>
+              <a:t>Exercise 06 · 90 min · Bonus</a:t>
+            </a:r>
+          </a:p>
+        </p:txBody>
+      </p:sp>
+      <p:sp>
+        <p:nvSpPr>
+          <p:cNvPr id="4" name="Title 3"/>
+          <p:cNvSpPr>
+            <a:spLocks noGrp="1"/>
+          </p:cNvSpPr>
+          <p:nvPr>
+            <p:ph type="ctrTitle"/>
+          </p:nvPr>
+        </p:nvSpPr>
+        <p:spPr/>
+        <p:txBody>
+          <a:bodyPr/>
+          <a:lstStyle/>
+          <a:p>
+            <a:r>
+              <a:t>Agents, Skills &amp; MCP</a:t>
+            </a:r>
+          </a:p>
+        </p:txBody>
+      </p:sp>
+      <p:sp>
+        <p:nvSpPr>
+          <p:cNvPr id="5" name="Text Placeholder 4"/>
+          <p:cNvSpPr>
+            <a:spLocks noGrp="1"/>
+          </p:cNvSpPr>
+          <p:nvPr>
+            <p:ph type="body" idx="10" sz="quarter"/>
+          </p:nvPr>
+        </p:nvSpPr>
+        <p:spPr/>
+        <p:txBody>
+          <a:bodyPr/>
+          <a:lstStyle/>
+          <a:p/>
+        </p:txBody>
+      </p:sp>
+    </p:spTree>
+  </p:cSld>
+  <p:clrMapOvr>
+    <a:masterClrMapping/>
+  </p:clrMapOvr>
+</p:sld>
+</file>
+
 <file path=ppt/slides/slide2.xml><?xml version="1.0" encoding="utf-8"?>
 <p:sld xmlns:a="http://schemas.openxmlformats.org/drawingml/2006/main" xmlns:r="http://schemas.openxmlformats.org/officeDocument/2006/relationships" xmlns:p="http://schemas.openxmlformats.org/presentationml/2006/main">
   <p:cSld>
@@ -7929,6 +8500,119 @@
         <p14:creationId xmlns:p14="http://schemas.microsoft.com/office/powerpoint/2010/main" val="2507593852"/>
       </p:ext>
     </p:extLst>
+  </p:cSld>
+  <p:clrMapOvr>
+    <a:masterClrMapping/>
+  </p:clrMapOvr>
+</p:sld>
+</file>
+
+<file path=ppt/slides/slide9.xml><?xml version="1.0" encoding="utf-8"?>
+<p:sld xmlns:a="http://schemas.openxmlformats.org/drawingml/2006/main" xmlns:p="http://schemas.openxmlformats.org/presentationml/2006/main" xmlns:r="http://schemas.openxmlformats.org/officeDocument/2006/relationships">
+  <p:cSld>
+    <p:spTree>
+      <p:nvGrpSpPr>
+        <p:cNvPr id="1" name=""/>
+        <p:cNvGrpSpPr/>
+        <p:nvPr/>
+      </p:nvGrpSpPr>
+      <p:grpSpPr/>
+      <p:sp>
+        <p:nvSpPr>
+          <p:cNvPr id="2" name="Content Placeholder 1"/>
+          <p:cNvSpPr>
+            <a:spLocks noGrp="1"/>
+          </p:cNvSpPr>
+          <p:nvPr>
+            <p:ph idx="1"/>
+          </p:nvPr>
+        </p:nvSpPr>
+        <p:spPr/>
+        <p:txBody>
+          <a:bodyPr/>
+          <a:lstStyle/>
+          <a:p>
+            <a:r>
+              <a:t>Get comfortable with Copilot's core code suggestions.</a:t>
+            </a:r>
+          </a:p>
+          <a:p>
+            <a:r>
+              <a:t>Verify Copilot is active, then trigger a suggestion from a comment.</a:t>
+            </a:r>
+          </a:p>
+          <a:p>
+            <a:r>
+              <a:t>Cycle alternatives with Alt+] / Alt+[ and accept with Tab.</a:t>
+            </a:r>
+          </a:p>
+          <a:p>
+            <a:r>
+              <a:t>Let inline completion finish a function for you.</a:t>
+            </a:r>
+          </a:p>
+        </p:txBody>
+      </p:sp>
+      <p:sp>
+        <p:nvSpPr>
+          <p:cNvPr id="3" name="Text Placeholder 2"/>
+          <p:cNvSpPr>
+            <a:spLocks noGrp="1"/>
+          </p:cNvSpPr>
+          <p:nvPr>
+            <p:ph type="body" idx="32" sz="quarter"/>
+          </p:nvPr>
+        </p:nvSpPr>
+        <p:spPr/>
+        <p:txBody>
+          <a:bodyPr/>
+          <a:lstStyle/>
+          <a:p>
+            <a:r>
+              <a:t>Exercise 01 · 20 min</a:t>
+            </a:r>
+          </a:p>
+        </p:txBody>
+      </p:sp>
+      <p:sp>
+        <p:nvSpPr>
+          <p:cNvPr id="4" name="Title 3"/>
+          <p:cNvSpPr>
+            <a:spLocks noGrp="1"/>
+          </p:cNvSpPr>
+          <p:nvPr>
+            <p:ph type="ctrTitle"/>
+          </p:nvPr>
+        </p:nvSpPr>
+        <p:spPr/>
+        <p:txBody>
+          <a:bodyPr/>
+          <a:lstStyle/>
+          <a:p>
+            <a:r>
+              <a:t>Setup &amp; Basics</a:t>
+            </a:r>
+          </a:p>
+        </p:txBody>
+      </p:sp>
+      <p:sp>
+        <p:nvSpPr>
+          <p:cNvPr id="5" name="Text Placeholder 4"/>
+          <p:cNvSpPr>
+            <a:spLocks noGrp="1"/>
+          </p:cNvSpPr>
+          <p:nvPr>
+            <p:ph type="body" idx="10" sz="quarter"/>
+          </p:nvPr>
+        </p:nvSpPr>
+        <p:spPr/>
+        <p:txBody>
+          <a:bodyPr/>
+          <a:lstStyle/>
+          <a:p/>
+        </p:txBody>
+      </p:sp>
+    </p:spTree>
   </p:cSld>
   <p:clrMapOvr>
     <a:masterClrMapping/>

</xml_diff>

<commit_message>
Update workshop deck (re-saved copy)
Co-authored-by: Copilot App <223556219+Copilot@users.noreply.github.com>
</commit_message>
<xml_diff>
--- a/resources/github-copilot-workshop.pptx
+++ b/resources/github-copilot-workshop.pptx
@@ -5,7 +5,7 @@
     <p:sldMasterId id="2147483660" r:id="rId4"/>
   </p:sldMasterIdLst>
   <p:notesMasterIdLst>
-    <p:notesMasterId r:id="rId13"/>
+    <p:notesMasterId r:id="rId19"/>
   </p:notesMasterIdLst>
   <p:sldIdLst>
     <p:sldId id="651" r:id="rId5"/>
@@ -15,13 +15,13 @@
     <p:sldId id="658" r:id="rId9"/>
     <p:sldId id="659" r:id="rId10"/>
     <p:sldId id="660" r:id="rId11"/>
-    <p:sldId id="661" r:id="rId18"/>
-    <p:sldId id="662" r:id="rId19"/>
-    <p:sldId id="663" r:id="rId20"/>
-    <p:sldId id="664" r:id="rId21"/>
-    <p:sldId id="665" r:id="rId22"/>
-    <p:sldId id="666" r:id="rId23"/>
-    <p:sldId id="582" r:id="rId12"/>
+    <p:sldId id="661" r:id="rId12"/>
+    <p:sldId id="662" r:id="rId13"/>
+    <p:sldId id="663" r:id="rId14"/>
+    <p:sldId id="664" r:id="rId15"/>
+    <p:sldId id="665" r:id="rId16"/>
+    <p:sldId id="666" r:id="rId17"/>
+    <p:sldId id="582" r:id="rId18"/>
   </p:sldIdLst>
   <p:sldSz cx="12188825" cy="6858000"/>
   <p:notesSz cx="6858000" cy="9144000"/>
@@ -6749,7 +6749,7 @@
 </file>
 
 <file path=ppt/slides/slide10.xml><?xml version="1.0" encoding="utf-8"?>
-<p:sld xmlns:a="http://schemas.openxmlformats.org/drawingml/2006/main" xmlns:p="http://schemas.openxmlformats.org/presentationml/2006/main" xmlns:r="http://schemas.openxmlformats.org/officeDocument/2006/relationships">
+<p:sld xmlns:a="http://schemas.openxmlformats.org/drawingml/2006/main" xmlns:r="http://schemas.openxmlformats.org/officeDocument/2006/relationships" xmlns:p="http://schemas.openxmlformats.org/presentationml/2006/main">
   <p:cSld>
     <p:spTree>
       <p:nvGrpSpPr>
@@ -6757,7 +6757,14 @@
         <p:cNvGrpSpPr/>
         <p:nvPr/>
       </p:nvGrpSpPr>
-      <p:grpSpPr/>
+      <p:grpSpPr>
+        <a:xfrm>
+          <a:off x="0" y="0"/>
+          <a:ext cx="0" cy="0"/>
+          <a:chOff x="0" y="0"/>
+          <a:chExt cx="0" cy="0"/>
+        </a:xfrm>
+      </p:grpSpPr>
       <p:sp>
         <p:nvSpPr>
           <p:cNvPr id="2" name="Content Placeholder 1"/>
@@ -6774,22 +6781,22 @@
           <a:lstStyle/>
           <a:p>
             <a:r>
-              <a:t>Write clear comments that generate high-quality code.</a:t>
-            </a:r>
-          </a:p>
-          <a:p>
-            <a:r>
-              <a:t>Build data-structure, algorithm and business-logic functions.</a:t>
-            </a:r>
-          </a:p>
-          <a:p>
-            <a:r>
-              <a:t>Generate test cases straight from your comments.</a:t>
-            </a:r>
-          </a:p>
-          <a:p>
-            <a:r>
-              <a:t>Learn why specificity — inputs, outputs, edge cases — matters.</a:t>
+              <a:t>Master multi-line completion and working with partial code.</a:t>
+            </a:r>
+          </a:p>
+          <a:p>
+            <a:r>
+              <a:t>Complete functions, classes and async API calls.</a:t>
+            </a:r>
+          </a:p>
+          <a:p>
+            <a:r>
+              <a:t>Recognize loop, iteration and error-handling patterns.</a:t>
+            </a:r>
+          </a:p>
+          <a:p>
+            <a:r>
+              <a:t>Use context — names and imports — to steer suggestions.</a:t>
             </a:r>
           </a:p>
         </p:txBody>
@@ -6801,7 +6808,7 @@
             <a:spLocks noGrp="1"/>
           </p:cNvSpPr>
           <p:nvPr>
-            <p:ph type="body" idx="32" sz="quarter"/>
+            <p:ph type="body" sz="quarter" idx="32"/>
           </p:nvPr>
         </p:nvSpPr>
         <p:spPr/>
@@ -6810,7 +6817,7 @@
           <a:lstStyle/>
           <a:p>
             <a:r>
-              <a:t>Exercise 02 · 30 min</a:t>
+              <a:t>Exercise 03 · 30 min</a:t>
             </a:r>
           </a:p>
         </p:txBody>
@@ -6831,7 +6838,7 @@
           <a:lstStyle/>
           <a:p>
             <a:r>
-              <a:t>Comment-to-Code</a:t>
+              <a:t>Code Completion</a:t>
             </a:r>
           </a:p>
         </p:txBody>
@@ -6843,14 +6850,16 @@
             <a:spLocks noGrp="1"/>
           </p:cNvSpPr>
           <p:nvPr>
-            <p:ph type="body" idx="10" sz="quarter"/>
+            <p:ph type="body" sz="quarter" idx="10"/>
           </p:nvPr>
         </p:nvSpPr>
         <p:spPr/>
         <p:txBody>
           <a:bodyPr/>
           <a:lstStyle/>
-          <a:p/>
+          <a:p>
+            <a:endParaRPr/>
+          </a:p>
         </p:txBody>
       </p:sp>
     </p:spTree>
@@ -6862,7 +6871,7 @@
 </file>
 
 <file path=ppt/slides/slide11.xml><?xml version="1.0" encoding="utf-8"?>
-<p:sld xmlns:a="http://schemas.openxmlformats.org/drawingml/2006/main" xmlns:p="http://schemas.openxmlformats.org/presentationml/2006/main" xmlns:r="http://schemas.openxmlformats.org/officeDocument/2006/relationships">
+<p:sld xmlns:a="http://schemas.openxmlformats.org/drawingml/2006/main" xmlns:r="http://schemas.openxmlformats.org/officeDocument/2006/relationships" xmlns:p="http://schemas.openxmlformats.org/presentationml/2006/main">
   <p:cSld>
     <p:spTree>
       <p:nvGrpSpPr>
@@ -6870,7 +6879,14 @@
         <p:cNvGrpSpPr/>
         <p:nvPr/>
       </p:nvGrpSpPr>
-      <p:grpSpPr/>
+      <p:grpSpPr>
+        <a:xfrm>
+          <a:off x="0" y="0"/>
+          <a:ext cx="0" cy="0"/>
+          <a:chOff x="0" y="0"/>
+          <a:chExt cx="0" cy="0"/>
+        </a:xfrm>
+      </p:grpSpPr>
       <p:sp>
         <p:nvSpPr>
           <p:cNvPr id="2" name="Content Placeholder 1"/>
@@ -6887,22 +6903,22 @@
           <a:lstStyle/>
           <a:p>
             <a:r>
-              <a:t>Master multi-line completion and working with partial code.</a:t>
-            </a:r>
-          </a:p>
-          <a:p>
-            <a:r>
-              <a:t>Complete functions, classes and async API calls.</a:t>
-            </a:r>
-          </a:p>
-          <a:p>
-            <a:r>
-              <a:t>Recognize loop, iteration and error-handling patterns.</a:t>
-            </a:r>
-          </a:p>
-          <a:p>
-            <a:r>
-              <a:t>Use context — names and imports — to steer suggestions.</a:t>
+              <a:t>Explain, debug, document and test with Copilot Chat.</a:t>
+            </a:r>
+          </a:p>
+          <a:p>
+            <a:r>
+              <a:t>Use slash commands: /explain, /fix, /doc, /tests.</a:t>
+            </a:r>
+          </a:p>
+          <a:p>
+            <a:r>
+              <a:t>Optimize and refactor complex, nested functions.</a:t>
+            </a:r>
+          </a:p>
+          <a:p>
+            <a:r>
+              <a:t>Analyze code for security and quality issues.</a:t>
             </a:r>
           </a:p>
         </p:txBody>
@@ -6914,7 +6930,7 @@
             <a:spLocks noGrp="1"/>
           </p:cNvSpPr>
           <p:nvPr>
-            <p:ph type="body" idx="32" sz="quarter"/>
+            <p:ph type="body" sz="quarter" idx="32"/>
           </p:nvPr>
         </p:nvSpPr>
         <p:spPr/>
@@ -6923,7 +6939,7 @@
           <a:lstStyle/>
           <a:p>
             <a:r>
-              <a:t>Exercise 03 · 30 min</a:t>
+              <a:t>Exercise 04 · 45 min</a:t>
             </a:r>
           </a:p>
         </p:txBody>
@@ -6944,7 +6960,7 @@
           <a:lstStyle/>
           <a:p>
             <a:r>
-              <a:t>Code Completion</a:t>
+              <a:t>Copilot Chat</a:t>
             </a:r>
           </a:p>
         </p:txBody>
@@ -6956,14 +6972,16 @@
             <a:spLocks noGrp="1"/>
           </p:cNvSpPr>
           <p:nvPr>
-            <p:ph type="body" idx="10" sz="quarter"/>
+            <p:ph type="body" sz="quarter" idx="10"/>
           </p:nvPr>
         </p:nvSpPr>
         <p:spPr/>
         <p:txBody>
           <a:bodyPr/>
           <a:lstStyle/>
-          <a:p/>
+          <a:p>
+            <a:endParaRPr/>
+          </a:p>
         </p:txBody>
       </p:sp>
     </p:spTree>
@@ -6975,7 +6993,7 @@
 </file>
 
 <file path=ppt/slides/slide12.xml><?xml version="1.0" encoding="utf-8"?>
-<p:sld xmlns:a="http://schemas.openxmlformats.org/drawingml/2006/main" xmlns:p="http://schemas.openxmlformats.org/presentationml/2006/main" xmlns:r="http://schemas.openxmlformats.org/officeDocument/2006/relationships">
+<p:sld xmlns:a="http://schemas.openxmlformats.org/drawingml/2006/main" xmlns:r="http://schemas.openxmlformats.org/officeDocument/2006/relationships" xmlns:p="http://schemas.openxmlformats.org/presentationml/2006/main">
   <p:cSld>
     <p:spTree>
       <p:nvGrpSpPr>
@@ -6983,7 +7001,14 @@
         <p:cNvGrpSpPr/>
         <p:nvPr/>
       </p:nvGrpSpPr>
-      <p:grpSpPr/>
+      <p:grpSpPr>
+        <a:xfrm>
+          <a:off x="0" y="0"/>
+          <a:ext cx="0" cy="0"/>
+          <a:chOff x="0" y="0"/>
+          <a:chExt cx="0" cy="0"/>
+        </a:xfrm>
+      </p:grpSpPr>
       <p:sp>
         <p:nvSpPr>
           <p:cNvPr id="2" name="Content Placeholder 1"/>
@@ -7000,22 +7025,22 @@
           <a:lstStyle/>
           <a:p>
             <a:r>
-              <a:t>Explain, debug, document and test with Copilot Chat.</a:t>
-            </a:r>
-          </a:p>
-          <a:p>
-            <a:r>
-              <a:t>Use slash commands: /explain, /fix, /doc, /tests.</a:t>
-            </a:r>
-          </a:p>
-          <a:p>
-            <a:r>
-              <a:t>Optimize and refactor complex, nested functions.</a:t>
-            </a:r>
-          </a:p>
-          <a:p>
-            <a:r>
-              <a:t>Analyze code for security and quality issues.</a:t>
+              <a:t>Build a complete Task Manager — REST API + web UI.</a:t>
+            </a:r>
+          </a:p>
+          <a:p>
+            <a:r>
+              <a:t>Express server backed by an in-memory task store.</a:t>
+            </a:r>
+          </a:p>
+          <a:p>
+            <a:r>
+              <a:t>Interactive frontend that updates without a refresh.</a:t>
+            </a:r>
+          </a:p>
+          <a:p>
+            <a:r>
+              <a:t>Verify end-to-end in the browser and with curl.</a:t>
             </a:r>
           </a:p>
         </p:txBody>
@@ -7027,7 +7052,7 @@
             <a:spLocks noGrp="1"/>
           </p:cNvSpPr>
           <p:nvPr>
-            <p:ph type="body" idx="32" sz="quarter"/>
+            <p:ph type="body" sz="quarter" idx="32"/>
           </p:nvPr>
         </p:nvSpPr>
         <p:spPr/>
@@ -7036,7 +7061,7 @@
           <a:lstStyle/>
           <a:p>
             <a:r>
-              <a:t>Exercise 04 · 45 min</a:t>
+              <a:t>Exercise 05 · 60 min</a:t>
             </a:r>
           </a:p>
         </p:txBody>
@@ -7057,7 +7082,7 @@
           <a:lstStyle/>
           <a:p>
             <a:r>
-              <a:t>Copilot Chat</a:t>
+              <a:t>Real-World Project</a:t>
             </a:r>
           </a:p>
         </p:txBody>
@@ -7069,14 +7094,16 @@
             <a:spLocks noGrp="1"/>
           </p:cNvSpPr>
           <p:nvPr>
-            <p:ph type="body" idx="10" sz="quarter"/>
+            <p:ph type="body" sz="quarter" idx="10"/>
           </p:nvPr>
         </p:nvSpPr>
         <p:spPr/>
         <p:txBody>
           <a:bodyPr/>
           <a:lstStyle/>
-          <a:p/>
+          <a:p>
+            <a:endParaRPr/>
+          </a:p>
         </p:txBody>
       </p:sp>
     </p:spTree>
@@ -7088,7 +7115,7 @@
 </file>
 
 <file path=ppt/slides/slide13.xml><?xml version="1.0" encoding="utf-8"?>
-<p:sld xmlns:a="http://schemas.openxmlformats.org/drawingml/2006/main" xmlns:p="http://schemas.openxmlformats.org/presentationml/2006/main" xmlns:r="http://schemas.openxmlformats.org/officeDocument/2006/relationships">
+<p:sld xmlns:a="http://schemas.openxmlformats.org/drawingml/2006/main" xmlns:r="http://schemas.openxmlformats.org/officeDocument/2006/relationships" xmlns:p="http://schemas.openxmlformats.org/presentationml/2006/main">
   <p:cSld>
     <p:spTree>
       <p:nvGrpSpPr>
@@ -7096,7 +7123,14 @@
         <p:cNvGrpSpPr/>
         <p:nvPr/>
       </p:nvGrpSpPr>
-      <p:grpSpPr/>
+      <p:grpSpPr>
+        <a:xfrm>
+          <a:off x="0" y="0"/>
+          <a:ext cx="0" cy="0"/>
+          <a:chOff x="0" y="0"/>
+          <a:chExt cx="0" cy="0"/>
+        </a:xfrm>
+      </p:grpSpPr>
       <p:sp>
         <p:nvSpPr>
           <p:cNvPr id="2" name="Content Placeholder 1"/>
@@ -7113,22 +7147,22 @@
           <a:lstStyle/>
           <a:p>
             <a:r>
-              <a:t>Build a complete Task Manager — REST API + web UI.</a:t>
-            </a:r>
-          </a:p>
-          <a:p>
-            <a:r>
-              <a:t>Express server backed by an in-memory task store.</a:t>
-            </a:r>
-          </a:p>
-          <a:p>
-            <a:r>
-              <a:t>Interactive frontend that updates without a refresh.</a:t>
-            </a:r>
-          </a:p>
-          <a:p>
-            <a:r>
-              <a:t>Verify end-to-end in the browser and with curl.</a:t>
+              <a:t>Orchestrate an end-to-end feature with a custom agent.</a:t>
+            </a:r>
+          </a:p>
+          <a:p>
+            <a:r>
+              <a:t>Add repo instructions and a reusable task-crud skill.</a:t>
+            </a:r>
+          </a:p>
+          <a:p>
+            <a:r>
+              <a:t>Drive and verify the UI with the Playwright MCP server.</a:t>
+            </a:r>
+          </a:p>
+          <a:p>
+            <a:r>
+              <a:t>Run the implement → verify → fix → re-verify loop.</a:t>
             </a:r>
           </a:p>
         </p:txBody>
@@ -7140,7 +7174,7 @@
             <a:spLocks noGrp="1"/>
           </p:cNvSpPr>
           <p:nvPr>
-            <p:ph type="body" idx="32" sz="quarter"/>
+            <p:ph type="body" sz="quarter" idx="32"/>
           </p:nvPr>
         </p:nvSpPr>
         <p:spPr/>
@@ -7149,7 +7183,7 @@
           <a:lstStyle/>
           <a:p>
             <a:r>
-              <a:t>Exercise 05 · 60 min</a:t>
+              <a:t>Exercise 06 · 90 min · Bonus</a:t>
             </a:r>
           </a:p>
         </p:txBody>
@@ -7170,7 +7204,7 @@
           <a:lstStyle/>
           <a:p>
             <a:r>
-              <a:t>Real-World Project</a:t>
+              <a:t>Agents, Skills &amp; MCP</a:t>
             </a:r>
           </a:p>
         </p:txBody>
@@ -7182,14 +7216,16 @@
             <a:spLocks noGrp="1"/>
           </p:cNvSpPr>
           <p:nvPr>
-            <p:ph type="body" idx="10" sz="quarter"/>
+            <p:ph type="body" sz="quarter" idx="10"/>
           </p:nvPr>
         </p:nvSpPr>
         <p:spPr/>
         <p:txBody>
           <a:bodyPr/>
           <a:lstStyle/>
-          <a:p/>
+          <a:p>
+            <a:endParaRPr/>
+          </a:p>
         </p:txBody>
       </p:sp>
     </p:spTree>
@@ -7201,7 +7237,7 @@
 </file>
 
 <file path=ppt/slides/slide14.xml><?xml version="1.0" encoding="utf-8"?>
-<p:sld xmlns:a="http://schemas.openxmlformats.org/drawingml/2006/main" xmlns:p="http://schemas.openxmlformats.org/presentationml/2006/main" xmlns:r="http://schemas.openxmlformats.org/officeDocument/2006/relationships">
+<p:sld xmlns:a="http://schemas.openxmlformats.org/drawingml/2006/main" xmlns:r="http://schemas.openxmlformats.org/officeDocument/2006/relationships" xmlns:p="http://schemas.openxmlformats.org/presentationml/2006/main">
   <p:cSld>
     <p:spTree>
       <p:nvGrpSpPr>
@@ -7209,103 +7245,20 @@
         <p:cNvGrpSpPr/>
         <p:nvPr/>
       </p:nvGrpSpPr>
-      <p:grpSpPr/>
-      <p:sp>
-        <p:nvSpPr>
-          <p:cNvPr id="2" name="Content Placeholder 1"/>
-          <p:cNvSpPr>
-            <a:spLocks noGrp="1"/>
-          </p:cNvSpPr>
-          <p:nvPr>
-            <p:ph idx="1"/>
-          </p:nvPr>
-        </p:nvSpPr>
-        <p:spPr/>
-        <p:txBody>
-          <a:bodyPr/>
-          <a:lstStyle/>
-          <a:p>
-            <a:r>
-              <a:t>Orchestrate an end-to-end feature with a custom agent.</a:t>
-            </a:r>
-          </a:p>
-          <a:p>
-            <a:r>
-              <a:t>Add repo instructions and a reusable task-crud skill.</a:t>
-            </a:r>
-          </a:p>
-          <a:p>
-            <a:r>
-              <a:t>Drive and verify the UI with the Playwright MCP server.</a:t>
-            </a:r>
-          </a:p>
-          <a:p>
-            <a:r>
-              <a:t>Run the implement → verify → fix → re-verify loop.</a:t>
-            </a:r>
-          </a:p>
-        </p:txBody>
-      </p:sp>
-      <p:sp>
-        <p:nvSpPr>
-          <p:cNvPr id="3" name="Text Placeholder 2"/>
-          <p:cNvSpPr>
-            <a:spLocks noGrp="1"/>
-          </p:cNvSpPr>
-          <p:nvPr>
-            <p:ph type="body" idx="32" sz="quarter"/>
-          </p:nvPr>
-        </p:nvSpPr>
-        <p:spPr/>
-        <p:txBody>
-          <a:bodyPr/>
-          <a:lstStyle/>
-          <a:p>
-            <a:r>
-              <a:t>Exercise 06 · 90 min · Bonus</a:t>
-            </a:r>
-          </a:p>
-        </p:txBody>
-      </p:sp>
-      <p:sp>
-        <p:nvSpPr>
-          <p:cNvPr id="4" name="Title 3"/>
-          <p:cNvSpPr>
-            <a:spLocks noGrp="1"/>
-          </p:cNvSpPr>
-          <p:nvPr>
-            <p:ph type="ctrTitle"/>
-          </p:nvPr>
-        </p:nvSpPr>
-        <p:spPr/>
-        <p:txBody>
-          <a:bodyPr/>
-          <a:lstStyle/>
-          <a:p>
-            <a:r>
-              <a:t>Agents, Skills &amp; MCP</a:t>
-            </a:r>
-          </a:p>
-        </p:txBody>
-      </p:sp>
-      <p:sp>
-        <p:nvSpPr>
-          <p:cNvPr id="5" name="Text Placeholder 4"/>
-          <p:cNvSpPr>
-            <a:spLocks noGrp="1"/>
-          </p:cNvSpPr>
-          <p:nvPr>
-            <p:ph type="body" idx="10" sz="quarter"/>
-          </p:nvPr>
-        </p:nvSpPr>
-        <p:spPr/>
-        <p:txBody>
-          <a:bodyPr/>
-          <a:lstStyle/>
-          <a:p/>
-        </p:txBody>
-      </p:sp>
+      <p:grpSpPr>
+        <a:xfrm>
+          <a:off x="0" y="0"/>
+          <a:ext cx="0" cy="0"/>
+          <a:chOff x="0" y="0"/>
+          <a:chExt cx="0" cy="0"/>
+        </a:xfrm>
+      </p:grpSpPr>
     </p:spTree>
+    <p:extLst>
+      <p:ext uri="{BB962C8B-B14F-4D97-AF65-F5344CB8AC3E}">
+        <p14:creationId xmlns:p14="http://schemas.microsoft.com/office/powerpoint/2010/main" val="2507593852"/>
+      </p:ext>
+    </p:extLst>
   </p:cSld>
   <p:clrMapOvr>
     <a:masterClrMapping/>
@@ -7346,7 +7299,8 @@
           <a:lstStyle/>
           <a:p>
             <a:r>
-              <a:t>Meet your AI pair programmer — and learn to build with it.</a:t>
+              <a:rPr dirty="0"/>
+              <a:t>Meet your AI pair programmer  and learn to build with it.</a:t>
             </a:r>
           </a:p>
         </p:txBody>
@@ -8494,12 +8448,120 @@
           <a:chExt cx="0" cy="0"/>
         </a:xfrm>
       </p:grpSpPr>
+      <p:sp>
+        <p:nvSpPr>
+          <p:cNvPr id="2" name="Content Placeholder 1"/>
+          <p:cNvSpPr>
+            <a:spLocks noGrp="1"/>
+          </p:cNvSpPr>
+          <p:nvPr>
+            <p:ph idx="1"/>
+          </p:nvPr>
+        </p:nvSpPr>
+        <p:spPr>
+          <a:xfrm>
+            <a:off x="517791" y="1923552"/>
+            <a:ext cx="11379581" cy="1718100"/>
+          </a:xfrm>
+        </p:spPr>
+        <p:txBody>
+          <a:bodyPr/>
+          <a:lstStyle/>
+          <a:p>
+            <a:r>
+              <a:rPr dirty="0"/>
+              <a:t>Get comfortable with Copilot's core code suggestions.</a:t>
+            </a:r>
+          </a:p>
+          <a:p>
+            <a:r>
+              <a:rPr dirty="0"/>
+              <a:t>Verify Copilot is active, then trigger a suggestion from a comment.</a:t>
+            </a:r>
+          </a:p>
+          <a:p>
+            <a:r>
+              <a:rPr dirty="0"/>
+              <a:t>Cycle alternatives with Alt+] / Alt+[ and accept with Tab.</a:t>
+            </a:r>
+          </a:p>
+          <a:p>
+            <a:r>
+              <a:rPr dirty="0"/>
+              <a:t>Let inline completion finish a function for you.</a:t>
+            </a:r>
+          </a:p>
+        </p:txBody>
+      </p:sp>
+      <p:sp>
+        <p:nvSpPr>
+          <p:cNvPr id="3" name="Text Placeholder 2"/>
+          <p:cNvSpPr>
+            <a:spLocks noGrp="1"/>
+          </p:cNvSpPr>
+          <p:nvPr>
+            <p:ph type="body" sz="quarter" idx="32"/>
+          </p:nvPr>
+        </p:nvSpPr>
+        <p:spPr/>
+        <p:txBody>
+          <a:bodyPr/>
+          <a:lstStyle/>
+          <a:p>
+            <a:r>
+              <a:rPr dirty="0"/>
+              <a:t>Exercise 01 · 20 min</a:t>
+            </a:r>
+          </a:p>
+        </p:txBody>
+      </p:sp>
+      <p:sp>
+        <p:nvSpPr>
+          <p:cNvPr id="4" name="Title 3"/>
+          <p:cNvSpPr>
+            <a:spLocks noGrp="1"/>
+          </p:cNvSpPr>
+          <p:nvPr>
+            <p:ph type="ctrTitle"/>
+          </p:nvPr>
+        </p:nvSpPr>
+        <p:spPr>
+          <a:xfrm>
+            <a:off x="517792" y="1009083"/>
+            <a:ext cx="11379581" cy="882013"/>
+          </a:xfrm>
+        </p:spPr>
+        <p:txBody>
+          <a:bodyPr/>
+          <a:lstStyle/>
+          <a:p>
+            <a:r>
+              <a:rPr dirty="0"/>
+              <a:t>Setup &amp; Basics</a:t>
+            </a:r>
+          </a:p>
+        </p:txBody>
+      </p:sp>
+      <p:sp>
+        <p:nvSpPr>
+          <p:cNvPr id="5" name="Text Placeholder 4"/>
+          <p:cNvSpPr>
+            <a:spLocks noGrp="1"/>
+          </p:cNvSpPr>
+          <p:nvPr>
+            <p:ph type="body" sz="quarter" idx="10"/>
+          </p:nvPr>
+        </p:nvSpPr>
+        <p:spPr/>
+        <p:txBody>
+          <a:bodyPr/>
+          <a:lstStyle/>
+          <a:p>
+            <a:endParaRPr/>
+          </a:p>
+        </p:txBody>
+      </p:sp>
     </p:spTree>
-    <p:extLst>
-      <p:ext uri="{BB962C8B-B14F-4D97-AF65-F5344CB8AC3E}">
-        <p14:creationId xmlns:p14="http://schemas.microsoft.com/office/powerpoint/2010/main" val="2507593852"/>
-      </p:ext>
-    </p:extLst>
   </p:cSld>
   <p:clrMapOvr>
     <a:masterClrMapping/>
@@ -8508,7 +8570,7 @@
 </file>
 
 <file path=ppt/slides/slide9.xml><?xml version="1.0" encoding="utf-8"?>
-<p:sld xmlns:a="http://schemas.openxmlformats.org/drawingml/2006/main" xmlns:p="http://schemas.openxmlformats.org/presentationml/2006/main" xmlns:r="http://schemas.openxmlformats.org/officeDocument/2006/relationships">
+<p:sld xmlns:a="http://schemas.openxmlformats.org/drawingml/2006/main" xmlns:r="http://schemas.openxmlformats.org/officeDocument/2006/relationships" xmlns:p="http://schemas.openxmlformats.org/presentationml/2006/main">
   <p:cSld>
     <p:spTree>
       <p:nvGrpSpPr>
@@ -8516,7 +8578,14 @@
         <p:cNvGrpSpPr/>
         <p:nvPr/>
       </p:nvGrpSpPr>
-      <p:grpSpPr/>
+      <p:grpSpPr>
+        <a:xfrm>
+          <a:off x="0" y="0"/>
+          <a:ext cx="0" cy="0"/>
+          <a:chOff x="0" y="0"/>
+          <a:chExt cx="0" cy="0"/>
+        </a:xfrm>
+      </p:grpSpPr>
       <p:sp>
         <p:nvSpPr>
           <p:cNvPr id="2" name="Content Placeholder 1"/>
@@ -8533,22 +8602,26 @@
           <a:lstStyle/>
           <a:p>
             <a:r>
-              <a:t>Get comfortable with Copilot's core code suggestions.</a:t>
-            </a:r>
-          </a:p>
-          <a:p>
-            <a:r>
-              <a:t>Verify Copilot is active, then trigger a suggestion from a comment.</a:t>
-            </a:r>
-          </a:p>
-          <a:p>
-            <a:r>
-              <a:t>Cycle alternatives with Alt+] / Alt+[ and accept with Tab.</a:t>
-            </a:r>
-          </a:p>
-          <a:p>
-            <a:r>
-              <a:t>Let inline completion finish a function for you.</a:t>
+              <a:rPr dirty="0"/>
+              <a:t>Write clear comments that generate high-quality code.</a:t>
+            </a:r>
+          </a:p>
+          <a:p>
+            <a:r>
+              <a:rPr dirty="0"/>
+              <a:t>Build data-structure, algorithm and business-logic functions.</a:t>
+            </a:r>
+          </a:p>
+          <a:p>
+            <a:r>
+              <a:rPr dirty="0"/>
+              <a:t>Generate test cases straight from your comments.</a:t>
+            </a:r>
+          </a:p>
+          <a:p>
+            <a:r>
+              <a:rPr dirty="0"/>
+              <a:t>Learn why specificity — inputs, outputs, edge cases — matters.</a:t>
             </a:r>
           </a:p>
         </p:txBody>
@@ -8560,7 +8633,7 @@
             <a:spLocks noGrp="1"/>
           </p:cNvSpPr>
           <p:nvPr>
-            <p:ph type="body" idx="32" sz="quarter"/>
+            <p:ph type="body" sz="quarter" idx="32"/>
           </p:nvPr>
         </p:nvSpPr>
         <p:spPr/>
@@ -8569,7 +8642,7 @@
           <a:lstStyle/>
           <a:p>
             <a:r>
-              <a:t>Exercise 01 · 20 min</a:t>
+              <a:t>Exercise 02 · 30 min</a:t>
             </a:r>
           </a:p>
         </p:txBody>
@@ -8590,7 +8663,8 @@
           <a:lstStyle/>
           <a:p>
             <a:r>
-              <a:t>Setup &amp; Basics</a:t>
+              <a:rPr dirty="0"/>
+              <a:t>Comment-to-Code</a:t>
             </a:r>
           </a:p>
         </p:txBody>
@@ -8602,14 +8676,16 @@
             <a:spLocks noGrp="1"/>
           </p:cNvSpPr>
           <p:nvPr>
-            <p:ph type="body" idx="10" sz="quarter"/>
+            <p:ph type="body" sz="quarter" idx="10"/>
           </p:nvPr>
         </p:nvSpPr>
         <p:spPr/>
         <p:txBody>
           <a:bodyPr/>
           <a:lstStyle/>
-          <a:p/>
+          <a:p>
+            <a:endParaRPr/>
+          </a:p>
         </p:txBody>
       </p:sp>
     </p:spTree>
@@ -9137,6 +9213,20 @@
 </file>
 
 <file path=customXml/item1.xml><?xml version="1.0" encoding="utf-8"?>
+<p:properties xmlns:p="http://schemas.microsoft.com/office/2006/metadata/properties" xmlns:xsi="http://www.w3.org/2001/XMLSchema-instance" xmlns:pc="http://schemas.microsoft.com/office/infopath/2007/PartnerControls">
+  <documentManagement>
+    <ProductName xmlns="39208136-c58e-4e30-a1ea-e9b896dfd74b">GitHub Copilot, GitHub Actions, GitHub Advanced Security, GitHub Enterprise Cloud, GHC, GHA, GHAS, GHEC</ProductName>
+    <_ip_UnifiedCompliancePolicyUIAction xmlns="http://schemas.microsoft.com/sharepoint/v3" xsi:nil="true"/>
+    <Audience xmlns="39208136-c58e-4e30-a1ea-e9b896dfd74b" xsi:nil="true"/>
+    <_ip_UnifiedCompliancePolicyProperties xmlns="http://schemas.microsoft.com/sharepoint/v3" xsi:nil="true"/>
+    <LastUpdatedDate xmlns="39208136-c58e-4e30-a1ea-e9b896dfd74b" xsi:nil="true"/>
+    <Topic xmlns="39208136-c58e-4e30-a1ea-e9b896dfd74b" xsi:nil="true"/>
+    <Status xmlns="39208136-c58e-4e30-a1ea-e9b896dfd74b" xsi:nil="true"/>
+  </documentManagement>
+</p:properties>
+</file>
+
+<file path=customXml/item2.xml><?xml version="1.0" encoding="utf-8"?>
 <ct:contentTypeSchema xmlns:ct="http://schemas.microsoft.com/office/2006/metadata/contentType" xmlns:ma="http://schemas.microsoft.com/office/2006/metadata/properties/metaAttributes" ct:_="" ma:_="" ma:contentTypeName="Document" ma:contentTypeID="0x010100575BED04A73EC04F8606832822A6508B" ma:contentTypeVersion="11" ma:contentTypeDescription="Create a new document." ma:contentTypeScope="" ma:versionID="3ede87957b835f638e51dd9dd4d1449d">
   <xsd:schema xmlns:xsd="http://www.w3.org/2001/XMLSchema" xmlns:xs="http://www.w3.org/2001/XMLSchema" xmlns:p="http://schemas.microsoft.com/office/2006/metadata/properties" xmlns:ns1="http://schemas.microsoft.com/sharepoint/v3" xmlns:ns2="39208136-c58e-4e30-a1ea-e9b896dfd74b" targetNamespace="http://schemas.microsoft.com/office/2006/metadata/properties" ma:root="true" ma:fieldsID="d7956be1e318c982bedba1a35c9f1493" ns1:_="" ns2:_="">
     <xsd:import namespace="http://schemas.microsoft.com/sharepoint/v3"/>
@@ -9362,20 +9452,6 @@
 </ct:contentTypeSchema>
 </file>
 
-<file path=customXml/item2.xml><?xml version="1.0" encoding="utf-8"?>
-<p:properties xmlns:p="http://schemas.microsoft.com/office/2006/metadata/properties" xmlns:xsi="http://www.w3.org/2001/XMLSchema-instance" xmlns:pc="http://schemas.microsoft.com/office/infopath/2007/PartnerControls">
-  <documentManagement>
-    <ProductName xmlns="39208136-c58e-4e30-a1ea-e9b896dfd74b">GitHub Copilot, GitHub Actions, GitHub Advanced Security, GitHub Enterprise Cloud, GHC, GHA, GHAS, GHEC</ProductName>
-    <_ip_UnifiedCompliancePolicyUIAction xmlns="http://schemas.microsoft.com/sharepoint/v3" xsi:nil="true"/>
-    <Audience xmlns="39208136-c58e-4e30-a1ea-e9b896dfd74b" xsi:nil="true"/>
-    <_ip_UnifiedCompliancePolicyProperties xmlns="http://schemas.microsoft.com/sharepoint/v3" xsi:nil="true"/>
-    <LastUpdatedDate xmlns="39208136-c58e-4e30-a1ea-e9b896dfd74b" xsi:nil="true"/>
-    <Topic xmlns="39208136-c58e-4e30-a1ea-e9b896dfd74b" xsi:nil="true"/>
-    <Status xmlns="39208136-c58e-4e30-a1ea-e9b896dfd74b" xsi:nil="true"/>
-  </documentManagement>
-</p:properties>
-</file>
-
 <file path=customXml/item3.xml><?xml version="1.0" encoding="utf-8"?>
 <?mso-contentType ?>
 <FormTemplates xmlns="http://schemas.microsoft.com/sharepoint/v3/contenttype/forms">
@@ -9386,6 +9462,23 @@
 </file>
 
 <file path=customXml/itemProps1.xml><?xml version="1.0" encoding="utf-8"?>
+<ds:datastoreItem xmlns:ds="http://schemas.openxmlformats.org/officeDocument/2006/customXml" ds:itemID="{5B539F14-A8E4-4272-8072-DAD8D69DF4E5}">
+  <ds:schemaRefs>
+    <ds:schemaRef ds:uri="http://purl.org/dc/elements/1.1/"/>
+    <ds:schemaRef ds:uri="http://purl.org/dc/dcmitype/"/>
+    <ds:schemaRef ds:uri="http://schemas.microsoft.com/office/2006/documentManagement/types"/>
+    <ds:schemaRef ds:uri="39208136-c58e-4e30-a1ea-e9b896dfd74b"/>
+    <ds:schemaRef ds:uri="http://schemas.openxmlformats.org/package/2006/metadata/core-properties"/>
+    <ds:schemaRef ds:uri="http://schemas.microsoft.com/office/2006/metadata/properties"/>
+    <ds:schemaRef ds:uri="http://schemas.microsoft.com/sharepoint/v3"/>
+    <ds:schemaRef ds:uri="http://purl.org/dc/terms/"/>
+    <ds:schemaRef ds:uri="http://schemas.microsoft.com/office/infopath/2007/PartnerControls"/>
+    <ds:schemaRef ds:uri="http://www.w3.org/XML/1998/namespace"/>
+  </ds:schemaRefs>
+</ds:datastoreItem>
+</file>
+
+<file path=customXml/itemProps2.xml><?xml version="1.0" encoding="utf-8"?>
 <ds:datastoreItem xmlns:ds="http://schemas.openxmlformats.org/officeDocument/2006/customXml" ds:itemID="{6D6951A7-F0FD-40B9-9CCF-618617AD55DB}">
   <ds:schemaRefs>
     <ds:schemaRef ds:uri="http://schemas.microsoft.com/office/2006/metadata/contentType"/>
@@ -9404,23 +9497,6 @@
 </ds:datastoreItem>
 </file>
 
-<file path=customXml/itemProps2.xml><?xml version="1.0" encoding="utf-8"?>
-<ds:datastoreItem xmlns:ds="http://schemas.openxmlformats.org/officeDocument/2006/customXml" ds:itemID="{5B539F14-A8E4-4272-8072-DAD8D69DF4E5}">
-  <ds:schemaRefs>
-    <ds:schemaRef ds:uri="http://purl.org/dc/elements/1.1/"/>
-    <ds:schemaRef ds:uri="http://purl.org/dc/dcmitype/"/>
-    <ds:schemaRef ds:uri="http://schemas.microsoft.com/office/2006/documentManagement/types"/>
-    <ds:schemaRef ds:uri="39208136-c58e-4e30-a1ea-e9b896dfd74b"/>
-    <ds:schemaRef ds:uri="http://schemas.openxmlformats.org/package/2006/metadata/core-properties"/>
-    <ds:schemaRef ds:uri="http://schemas.microsoft.com/office/2006/metadata/properties"/>
-    <ds:schemaRef ds:uri="http://schemas.microsoft.com/sharepoint/v3"/>
-    <ds:schemaRef ds:uri="http://purl.org/dc/terms/"/>
-    <ds:schemaRef ds:uri="http://schemas.microsoft.com/office/infopath/2007/PartnerControls"/>
-    <ds:schemaRef ds:uri="http://www.w3.org/XML/1998/namespace"/>
-  </ds:schemaRefs>
-</ds:datastoreItem>
-</file>
-
 <file path=customXml/itemProps3.xml><?xml version="1.0" encoding="utf-8"?>
 <ds:datastoreItem xmlns:ds="http://schemas.openxmlformats.org/officeDocument/2006/customXml" ds:itemID="{AB543426-3F68-4F40-8364-AB61CAE32945}">
   <ds:schemaRefs>

</xml_diff>